<commit_message>
Remove speaker timings from slide rails
The timings were rendering on the projected slide. They belong to the
presenter, not the audience, so they now live only in each slide's notes
pane and in SPEAKER_NOTES.md. rail() no longer takes a timing argument.

Also ignore PowerPoint ~$ owner-lock files.
</commit_message>
<xml_diff>
--- a/build/CLL798_prelim_5min.pptx
+++ b/build/CLL798_prelim_5min.pptx
@@ -4417,46 +4417,7 @@
       </p:sp>
       <p:sp>
         <p:nvSpPr>
-          <p:cNvPr id="3" name="TextBox 2"/>
-          <p:cNvSpPr txBox="1"/>
-          <p:nvPr/>
-        </p:nvSpPr>
-        <p:spPr>
-          <a:xfrm>
-            <a:off x="8973007" y="274320"/>
-            <a:ext cx="2743200" cy="274320"/>
-          </a:xfrm>
-          <a:prstGeom prst="rect">
-            <a:avLst/>
-          </a:prstGeom>
-          <a:noFill/>
-        </p:spPr>
-        <p:txBody>
-          <a:bodyPr wrap="square" anchor="t" lIns="0" rIns="0" tIns="0" bIns="0">
-            <a:spAutoFit/>
-          </a:bodyPr>
-          <a:lstStyle/>
-          <a:p>
-            <a:pPr algn="r">
-              <a:spcAft>
-                <a:spcPts val="0"/>
-              </a:spcAft>
-            </a:pPr>
-            <a:r>
-              <a:rPr sz="1150" b="0">
-                <a:solidFill>
-                  <a:srgbClr val="8098A1"/>
-                </a:solidFill>
-                <a:latin typeface="Consolas"/>
-              </a:rPr>
-              <a:t>0:45  |  running 1:00</a:t>
-            </a:r>
-          </a:p>
-        </p:txBody>
-      </p:sp>
-      <p:sp>
-        <p:nvSpPr>
-          <p:cNvPr id="4" name="Rectangle 3"/>
+          <p:cNvPr id="3" name="Rectangle 2"/>
           <p:cNvSpPr/>
           <p:nvPr/>
         </p:nvSpPr>
@@ -4500,7 +4461,7 @@
       </p:sp>
       <p:sp>
         <p:nvSpPr>
-          <p:cNvPr id="5" name="TextBox 4"/>
+          <p:cNvPr id="4" name="TextBox 3"/>
           <p:cNvSpPr txBox="1"/>
           <p:nvPr/>
         </p:nvSpPr>
@@ -4542,7 +4503,7 @@
       </p:sp>
       <p:pic>
         <p:nvPicPr>
-          <p:cNvPr id="6" name="Picture 5" descr="fig1_networks.png"/>
+          <p:cNvPr id="5" name="Picture 4" descr="fig1_networks.png"/>
           <p:cNvPicPr>
             <a:picLocks noChangeAspect="1"/>
           </p:cNvPicPr>
@@ -4566,7 +4527,7 @@
       </p:pic>
       <p:sp>
         <p:nvSpPr>
-          <p:cNvPr id="7" name="TextBox 6"/>
+          <p:cNvPr id="6" name="TextBox 5"/>
           <p:cNvSpPr txBox="1"/>
           <p:nvPr/>
         </p:nvSpPr>
@@ -4687,7 +4648,7 @@
       </p:sp>
       <p:sp>
         <p:nvSpPr>
-          <p:cNvPr id="8" name="Rectangle 7"/>
+          <p:cNvPr id="7" name="Rectangle 6"/>
           <p:cNvSpPr/>
           <p:nvPr/>
         </p:nvSpPr>
@@ -4733,7 +4694,7 @@
       </p:sp>
       <p:sp>
         <p:nvSpPr>
-          <p:cNvPr id="9" name="TextBox 8"/>
+          <p:cNvPr id="8" name="TextBox 7"/>
           <p:cNvSpPr txBox="1"/>
           <p:nvPr/>
         </p:nvSpPr>
@@ -4810,7 +4771,7 @@
       </p:sp>
       <p:sp>
         <p:nvSpPr>
-          <p:cNvPr id="10" name="Rectangle 9"/>
+          <p:cNvPr id="9" name="Rectangle 8"/>
           <p:cNvSpPr/>
           <p:nvPr/>
         </p:nvSpPr>
@@ -4856,7 +4817,7 @@
       </p:sp>
       <p:sp>
         <p:nvSpPr>
-          <p:cNvPr id="11" name="TextBox 10"/>
+          <p:cNvPr id="10" name="TextBox 9"/>
           <p:cNvSpPr txBox="1"/>
           <p:nvPr/>
         </p:nvSpPr>
@@ -4933,7 +4894,7 @@
       </p:sp>
       <p:sp>
         <p:nvSpPr>
-          <p:cNvPr id="12" name="Rectangle 11"/>
+          <p:cNvPr id="11" name="Rectangle 10"/>
           <p:cNvSpPr/>
           <p:nvPr/>
         </p:nvSpPr>
@@ -4979,7 +4940,7 @@
       </p:sp>
       <p:sp>
         <p:nvSpPr>
-          <p:cNvPr id="13" name="TextBox 12"/>
+          <p:cNvPr id="12" name="TextBox 11"/>
           <p:cNvSpPr txBox="1"/>
           <p:nvPr/>
         </p:nvSpPr>
@@ -5130,46 +5091,7 @@
       </p:sp>
       <p:sp>
         <p:nvSpPr>
-          <p:cNvPr id="3" name="TextBox 2"/>
-          <p:cNvSpPr txBox="1"/>
-          <p:nvPr/>
-        </p:nvSpPr>
-        <p:spPr>
-          <a:xfrm>
-            <a:off x="8973007" y="274320"/>
-            <a:ext cx="2743200" cy="274320"/>
-          </a:xfrm>
-          <a:prstGeom prst="rect">
-            <a:avLst/>
-          </a:prstGeom>
-          <a:noFill/>
-        </p:spPr>
-        <p:txBody>
-          <a:bodyPr wrap="square" anchor="t" lIns="0" rIns="0" tIns="0" bIns="0">
-            <a:spAutoFit/>
-          </a:bodyPr>
-          <a:lstStyle/>
-          <a:p>
-            <a:pPr algn="r">
-              <a:spcAft>
-                <a:spcPts val="0"/>
-              </a:spcAft>
-            </a:pPr>
-            <a:r>
-              <a:rPr sz="1150" b="0">
-                <a:solidFill>
-                  <a:srgbClr val="8098A1"/>
-                </a:solidFill>
-                <a:latin typeface="Consolas"/>
-              </a:rPr>
-              <a:t>0:55  |  running 1:55</a:t>
-            </a:r>
-          </a:p>
-        </p:txBody>
-      </p:sp>
-      <p:sp>
-        <p:nvSpPr>
-          <p:cNvPr id="4" name="Rectangle 3"/>
+          <p:cNvPr id="3" name="Rectangle 2"/>
           <p:cNvSpPr/>
           <p:nvPr/>
         </p:nvSpPr>
@@ -5213,7 +5135,7 @@
       </p:sp>
       <p:sp>
         <p:nvSpPr>
-          <p:cNvPr id="5" name="TextBox 4"/>
+          <p:cNvPr id="4" name="TextBox 3"/>
           <p:cNvSpPr txBox="1"/>
           <p:nvPr/>
         </p:nvSpPr>
@@ -5255,7 +5177,7 @@
       </p:sp>
       <p:pic>
         <p:nvPicPr>
-          <p:cNvPr id="6" name="Picture 5" descr="fig3_terrain_effect.png"/>
+          <p:cNvPr id="5" name="Picture 4" descr="fig3_terrain_effect.png"/>
           <p:cNvPicPr>
             <a:picLocks noChangeAspect="1"/>
           </p:cNvPicPr>
@@ -5279,7 +5201,7 @@
       </p:pic>
       <p:sp>
         <p:nvSpPr>
-          <p:cNvPr id="7" name="Rectangle 6"/>
+          <p:cNvPr id="6" name="Rectangle 5"/>
           <p:cNvSpPr/>
           <p:nvPr/>
         </p:nvSpPr>
@@ -5325,7 +5247,7 @@
       </p:sp>
       <p:sp>
         <p:nvSpPr>
-          <p:cNvPr id="8" name="TextBox 7"/>
+          <p:cNvPr id="7" name="TextBox 6"/>
           <p:cNvSpPr txBox="1"/>
           <p:nvPr/>
         </p:nvSpPr>
@@ -5402,7 +5324,7 @@
       </p:sp>
       <p:sp>
         <p:nvSpPr>
-          <p:cNvPr id="9" name="Rectangle 8"/>
+          <p:cNvPr id="8" name="Rectangle 7"/>
           <p:cNvSpPr/>
           <p:nvPr/>
         </p:nvSpPr>
@@ -5448,7 +5370,7 @@
       </p:sp>
       <p:sp>
         <p:nvSpPr>
-          <p:cNvPr id="10" name="TextBox 9"/>
+          <p:cNvPr id="9" name="TextBox 8"/>
           <p:cNvSpPr txBox="1"/>
           <p:nvPr/>
         </p:nvSpPr>
@@ -5525,7 +5447,7 @@
       </p:sp>
       <p:sp>
         <p:nvSpPr>
-          <p:cNvPr id="11" name="Rectangle 10"/>
+          <p:cNvPr id="10" name="Rectangle 9"/>
           <p:cNvSpPr/>
           <p:nvPr/>
         </p:nvSpPr>
@@ -5569,7 +5491,7 @@
       </p:sp>
       <p:sp>
         <p:nvSpPr>
-          <p:cNvPr id="12" name="TextBox 11"/>
+          <p:cNvPr id="11" name="TextBox 10"/>
           <p:cNvSpPr txBox="1"/>
           <p:nvPr/>
         </p:nvSpPr>
@@ -5701,46 +5623,7 @@
       </p:sp>
       <p:sp>
         <p:nvSpPr>
-          <p:cNvPr id="3" name="TextBox 2"/>
-          <p:cNvSpPr txBox="1"/>
-          <p:nvPr/>
-        </p:nvSpPr>
-        <p:spPr>
-          <a:xfrm>
-            <a:off x="8973007" y="274320"/>
-            <a:ext cx="2743200" cy="274320"/>
-          </a:xfrm>
-          <a:prstGeom prst="rect">
-            <a:avLst/>
-          </a:prstGeom>
-          <a:noFill/>
-        </p:spPr>
-        <p:txBody>
-          <a:bodyPr wrap="square" anchor="t" lIns="0" rIns="0" tIns="0" bIns="0">
-            <a:spAutoFit/>
-          </a:bodyPr>
-          <a:lstStyle/>
-          <a:p>
-            <a:pPr algn="r">
-              <a:spcAft>
-                <a:spcPts val="0"/>
-              </a:spcAft>
-            </a:pPr>
-            <a:r>
-              <a:rPr sz="1150" b="0">
-                <a:solidFill>
-                  <a:srgbClr val="8098A1"/>
-                </a:solidFill>
-                <a:latin typeface="Consolas"/>
-              </a:rPr>
-              <a:t>0:55  |  running 2:50</a:t>
-            </a:r>
-          </a:p>
-        </p:txBody>
-      </p:sp>
-      <p:sp>
-        <p:nvSpPr>
-          <p:cNvPr id="4" name="Rectangle 3"/>
+          <p:cNvPr id="3" name="Rectangle 2"/>
           <p:cNvSpPr/>
           <p:nvPr/>
         </p:nvSpPr>
@@ -5784,7 +5667,7 @@
       </p:sp>
       <p:sp>
         <p:nvSpPr>
-          <p:cNvPr id="5" name="TextBox 4"/>
+          <p:cNvPr id="4" name="TextBox 3"/>
           <p:cNvSpPr txBox="1"/>
           <p:nvPr/>
         </p:nvSpPr>
@@ -5826,7 +5709,7 @@
       </p:sp>
       <p:pic>
         <p:nvPicPr>
-          <p:cNvPr id="6" name="Picture 5" descr="fig8_pressure_zones.png"/>
+          <p:cNvPr id="5" name="Picture 4" descr="fig8_pressure_zones.png"/>
           <p:cNvPicPr>
             <a:picLocks noChangeAspect="1"/>
           </p:cNvPicPr>
@@ -5850,7 +5733,7 @@
       </p:pic>
       <p:sp>
         <p:nvSpPr>
-          <p:cNvPr id="7" name="TextBox 6"/>
+          <p:cNvPr id="6" name="TextBox 5"/>
           <p:cNvSpPr txBox="1"/>
           <p:nvPr/>
         </p:nvSpPr>
@@ -5980,7 +5863,7 @@
       </p:sp>
       <p:sp>
         <p:nvSpPr>
-          <p:cNvPr id="8" name="Rectangle 7"/>
+          <p:cNvPr id="7" name="Rectangle 6"/>
           <p:cNvSpPr/>
           <p:nvPr/>
         </p:nvSpPr>
@@ -6026,7 +5909,7 @@
       </p:sp>
       <p:sp>
         <p:nvSpPr>
-          <p:cNvPr id="9" name="TextBox 8"/>
+          <p:cNvPr id="8" name="TextBox 7"/>
           <p:cNvSpPr txBox="1"/>
           <p:nvPr/>
         </p:nvSpPr>
@@ -6103,7 +5986,7 @@
       </p:sp>
       <p:sp>
         <p:nvSpPr>
-          <p:cNvPr id="10" name="Rectangle 9"/>
+          <p:cNvPr id="9" name="Rectangle 8"/>
           <p:cNvSpPr/>
           <p:nvPr/>
         </p:nvSpPr>
@@ -6147,7 +6030,7 @@
       </p:sp>
       <p:sp>
         <p:nvSpPr>
-          <p:cNvPr id="11" name="TextBox 10"/>
+          <p:cNvPr id="10" name="TextBox 9"/>
           <p:cNvSpPr txBox="1"/>
           <p:nvPr/>
         </p:nvSpPr>
@@ -6279,46 +6162,7 @@
       </p:sp>
       <p:sp>
         <p:nvSpPr>
-          <p:cNvPr id="3" name="TextBox 2"/>
-          <p:cNvSpPr txBox="1"/>
-          <p:nvPr/>
-        </p:nvSpPr>
-        <p:spPr>
-          <a:xfrm>
-            <a:off x="8973007" y="274320"/>
-            <a:ext cx="2743200" cy="274320"/>
-          </a:xfrm>
-          <a:prstGeom prst="rect">
-            <a:avLst/>
-          </a:prstGeom>
-          <a:noFill/>
-        </p:spPr>
-        <p:txBody>
-          <a:bodyPr wrap="square" anchor="t" lIns="0" rIns="0" tIns="0" bIns="0">
-            <a:spAutoFit/>
-          </a:bodyPr>
-          <a:lstStyle/>
-          <a:p>
-            <a:pPr algn="r">
-              <a:spcAft>
-                <a:spcPts val="0"/>
-              </a:spcAft>
-            </a:pPr>
-            <a:r>
-              <a:rPr sz="1150" b="0">
-                <a:solidFill>
-                  <a:srgbClr val="8098A1"/>
-                </a:solidFill>
-                <a:latin typeface="Consolas"/>
-              </a:rPr>
-              <a:t>1:00  |  running 3:50</a:t>
-            </a:r>
-          </a:p>
-        </p:txBody>
-      </p:sp>
-      <p:sp>
-        <p:nvSpPr>
-          <p:cNvPr id="4" name="Rectangle 3"/>
+          <p:cNvPr id="3" name="Rectangle 2"/>
           <p:cNvSpPr/>
           <p:nvPr/>
         </p:nvSpPr>
@@ -6362,7 +6206,7 @@
       </p:sp>
       <p:sp>
         <p:nvSpPr>
-          <p:cNvPr id="5" name="TextBox 4"/>
+          <p:cNvPr id="4" name="TextBox 3"/>
           <p:cNvSpPr txBox="1"/>
           <p:nvPr/>
         </p:nvSpPr>
@@ -6404,7 +6248,7 @@
       </p:sp>
       <p:pic>
         <p:nvPicPr>
-          <p:cNvPr id="6" name="Picture 5" descr="fig4_reliability.png"/>
+          <p:cNvPr id="5" name="Picture 4" descr="fig4_reliability.png"/>
           <p:cNvPicPr>
             <a:picLocks noChangeAspect="1"/>
           </p:cNvPicPr>
@@ -6428,7 +6272,7 @@
       </p:pic>
       <p:sp>
         <p:nvSpPr>
-          <p:cNvPr id="7" name="TextBox 6"/>
+          <p:cNvPr id="6" name="TextBox 5"/>
           <p:cNvSpPr txBox="1"/>
           <p:nvPr/>
         </p:nvSpPr>
@@ -6639,7 +6483,7 @@
       </p:sp>
       <p:sp>
         <p:nvSpPr>
-          <p:cNvPr id="8" name="Rectangle 7"/>
+          <p:cNvPr id="7" name="Rectangle 6"/>
           <p:cNvSpPr/>
           <p:nvPr/>
         </p:nvSpPr>
@@ -6683,7 +6527,7 @@
       </p:sp>
       <p:sp>
         <p:nvSpPr>
-          <p:cNvPr id="9" name="TextBox 8"/>
+          <p:cNvPr id="8" name="TextBox 7"/>
           <p:cNvSpPr txBox="1"/>
           <p:nvPr/>
         </p:nvSpPr>
@@ -6741,7 +6585,7 @@
       </p:sp>
       <p:sp>
         <p:nvSpPr>
-          <p:cNvPr id="10" name="Rectangle 9"/>
+          <p:cNvPr id="9" name="Rectangle 8"/>
           <p:cNvSpPr/>
           <p:nvPr/>
         </p:nvSpPr>
@@ -6785,7 +6629,7 @@
       </p:sp>
       <p:sp>
         <p:nvSpPr>
-          <p:cNvPr id="11" name="TextBox 10"/>
+          <p:cNvPr id="10" name="TextBox 9"/>
           <p:cNvSpPr txBox="1"/>
           <p:nvPr/>
         </p:nvSpPr>
@@ -6917,46 +6761,7 @@
       </p:sp>
       <p:sp>
         <p:nvSpPr>
-          <p:cNvPr id="3" name="TextBox 2"/>
-          <p:cNvSpPr txBox="1"/>
-          <p:nvPr/>
-        </p:nvSpPr>
-        <p:spPr>
-          <a:xfrm>
-            <a:off x="8973007" y="274320"/>
-            <a:ext cx="2743200" cy="274320"/>
-          </a:xfrm>
-          <a:prstGeom prst="rect">
-            <a:avLst/>
-          </a:prstGeom>
-          <a:noFill/>
-        </p:spPr>
-        <p:txBody>
-          <a:bodyPr wrap="square" anchor="t" lIns="0" rIns="0" tIns="0" bIns="0">
-            <a:spAutoFit/>
-          </a:bodyPr>
-          <a:lstStyle/>
-          <a:p>
-            <a:pPr algn="r">
-              <a:spcAft>
-                <a:spcPts val="0"/>
-              </a:spcAft>
-            </a:pPr>
-            <a:r>
-              <a:rPr sz="1150" b="0">
-                <a:solidFill>
-                  <a:srgbClr val="8098A1"/>
-                </a:solidFill>
-                <a:latin typeface="Consolas"/>
-              </a:rPr>
-              <a:t>0:50  |  running 4:40</a:t>
-            </a:r>
-          </a:p>
-        </p:txBody>
-      </p:sp>
-      <p:sp>
-        <p:nvSpPr>
-          <p:cNvPr id="4" name="Rectangle 3"/>
+          <p:cNvPr id="3" name="Rectangle 2"/>
           <p:cNvSpPr/>
           <p:nvPr/>
         </p:nvSpPr>
@@ -7000,7 +6805,7 @@
       </p:sp>
       <p:sp>
         <p:nvSpPr>
-          <p:cNvPr id="5" name="TextBox 4"/>
+          <p:cNvPr id="4" name="TextBox 3"/>
           <p:cNvSpPr txBox="1"/>
           <p:nvPr/>
         </p:nvSpPr>
@@ -7042,7 +6847,7 @@
       </p:sp>
       <p:pic>
         <p:nvPicPr>
-          <p:cNvPr id="6" name="Picture 5" descr="fig5_algorithms.png"/>
+          <p:cNvPr id="5" name="Picture 4" descr="fig5_algorithms.png"/>
           <p:cNvPicPr>
             <a:picLocks noChangeAspect="1"/>
           </p:cNvPicPr>
@@ -7066,7 +6871,7 @@
       </p:pic>
       <p:sp>
         <p:nvSpPr>
-          <p:cNvPr id="7" name="TextBox 6"/>
+          <p:cNvPr id="6" name="TextBox 5"/>
           <p:cNvSpPr txBox="1"/>
           <p:nvPr/>
         </p:nvSpPr>
@@ -7180,7 +6985,7 @@
       </p:sp>
       <p:sp>
         <p:nvSpPr>
-          <p:cNvPr id="8" name="Rectangle 7"/>
+          <p:cNvPr id="7" name="Rectangle 6"/>
           <p:cNvSpPr/>
           <p:nvPr/>
         </p:nvSpPr>
@@ -7224,7 +7029,7 @@
       </p:sp>
       <p:sp>
         <p:nvSpPr>
-          <p:cNvPr id="9" name="TextBox 8"/>
+          <p:cNvPr id="8" name="TextBox 7"/>
           <p:cNvSpPr txBox="1"/>
           <p:nvPr/>
         </p:nvSpPr>
@@ -7282,7 +7087,7 @@
       </p:sp>
       <p:sp>
         <p:nvSpPr>
-          <p:cNvPr id="10" name="Rectangle 9"/>
+          <p:cNvPr id="9" name="Rectangle 8"/>
           <p:cNvSpPr/>
           <p:nvPr/>
         </p:nvSpPr>
@@ -7326,7 +7131,7 @@
       </p:sp>
       <p:sp>
         <p:nvSpPr>
-          <p:cNvPr id="11" name="TextBox 10"/>
+          <p:cNvPr id="10" name="TextBox 9"/>
           <p:cNvSpPr txBox="1"/>
           <p:nvPr/>
         </p:nvSpPr>
@@ -7384,7 +7189,7 @@
       </p:sp>
       <p:sp>
         <p:nvSpPr>
-          <p:cNvPr id="12" name="Rectangle 11"/>
+          <p:cNvPr id="11" name="Rectangle 10"/>
           <p:cNvSpPr/>
           <p:nvPr/>
         </p:nvSpPr>
@@ -7428,7 +7233,7 @@
       </p:sp>
       <p:sp>
         <p:nvSpPr>
-          <p:cNvPr id="13" name="TextBox 12"/>
+          <p:cNvPr id="12" name="TextBox 11"/>
           <p:cNvSpPr txBox="1"/>
           <p:nvPr/>
         </p:nvSpPr>
@@ -7560,46 +7365,7 @@
       </p:sp>
       <p:sp>
         <p:nvSpPr>
-          <p:cNvPr id="3" name="TextBox 2"/>
-          <p:cNvSpPr txBox="1"/>
-          <p:nvPr/>
-        </p:nvSpPr>
-        <p:spPr>
-          <a:xfrm>
-            <a:off x="8973007" y="274320"/>
-            <a:ext cx="2743200" cy="274320"/>
-          </a:xfrm>
-          <a:prstGeom prst="rect">
-            <a:avLst/>
-          </a:prstGeom>
-          <a:noFill/>
-        </p:spPr>
-        <p:txBody>
-          <a:bodyPr wrap="square" anchor="t" lIns="0" rIns="0" tIns="0" bIns="0">
-            <a:spAutoFit/>
-          </a:bodyPr>
-          <a:lstStyle/>
-          <a:p>
-            <a:pPr algn="r">
-              <a:spcAft>
-                <a:spcPts val="0"/>
-              </a:spcAft>
-            </a:pPr>
-            <a:r>
-              <a:rPr sz="1150" b="0">
-                <a:solidFill>
-                  <a:srgbClr val="8098A1"/>
-                </a:solidFill>
-                <a:latin typeface="Consolas"/>
-              </a:rPr>
-              <a:t>0:20  |  running 5:00</a:t>
-            </a:r>
-          </a:p>
-        </p:txBody>
-      </p:sp>
-      <p:sp>
-        <p:nvSpPr>
-          <p:cNvPr id="4" name="Rectangle 3"/>
+          <p:cNvPr id="3" name="Rectangle 2"/>
           <p:cNvSpPr/>
           <p:nvPr/>
         </p:nvSpPr>
@@ -7643,7 +7409,7 @@
       </p:sp>
       <p:sp>
         <p:nvSpPr>
-          <p:cNvPr id="5" name="TextBox 4"/>
+          <p:cNvPr id="4" name="TextBox 3"/>
           <p:cNvSpPr txBox="1"/>
           <p:nvPr/>
         </p:nvSpPr>
@@ -7685,7 +7451,7 @@
       </p:sp>
       <p:sp>
         <p:nvSpPr>
-          <p:cNvPr id="6" name="Rectangle 5"/>
+          <p:cNvPr id="5" name="Rectangle 4"/>
           <p:cNvSpPr/>
           <p:nvPr/>
         </p:nvSpPr>
@@ -7731,7 +7497,7 @@
       </p:sp>
       <p:sp>
         <p:nvSpPr>
-          <p:cNvPr id="7" name="TextBox 6"/>
+          <p:cNvPr id="6" name="TextBox 5"/>
           <p:cNvSpPr txBox="1"/>
           <p:nvPr/>
         </p:nvSpPr>
@@ -7808,7 +7574,7 @@
       </p:sp>
       <p:sp>
         <p:nvSpPr>
-          <p:cNvPr id="8" name="Rectangle 7"/>
+          <p:cNvPr id="7" name="Rectangle 6"/>
           <p:cNvSpPr/>
           <p:nvPr/>
         </p:nvSpPr>
@@ -7854,7 +7620,7 @@
       </p:sp>
       <p:sp>
         <p:nvSpPr>
-          <p:cNvPr id="9" name="TextBox 8"/>
+          <p:cNvPr id="8" name="TextBox 7"/>
           <p:cNvSpPr txBox="1"/>
           <p:nvPr/>
         </p:nvSpPr>
@@ -7931,7 +7697,7 @@
       </p:sp>
       <p:sp>
         <p:nvSpPr>
-          <p:cNvPr id="10" name="Rectangle 9"/>
+          <p:cNvPr id="9" name="Rectangle 8"/>
           <p:cNvSpPr/>
           <p:nvPr/>
         </p:nvSpPr>
@@ -7977,7 +7743,7 @@
       </p:sp>
       <p:sp>
         <p:nvSpPr>
-          <p:cNvPr id="11" name="TextBox 10"/>
+          <p:cNvPr id="10" name="TextBox 9"/>
           <p:cNvSpPr txBox="1"/>
           <p:nvPr/>
         </p:nvSpPr>
@@ -8054,7 +7820,7 @@
       </p:sp>
       <p:sp>
         <p:nvSpPr>
-          <p:cNvPr id="12" name="Rectangle 11"/>
+          <p:cNvPr id="11" name="Rectangle 10"/>
           <p:cNvSpPr/>
           <p:nvPr/>
         </p:nvSpPr>
@@ -8100,7 +7866,7 @@
       </p:sp>
       <p:sp>
         <p:nvSpPr>
-          <p:cNvPr id="13" name="TextBox 12"/>
+          <p:cNvPr id="12" name="TextBox 11"/>
           <p:cNvSpPr txBox="1"/>
           <p:nvPr/>
         </p:nvSpPr>
@@ -8177,7 +7943,7 @@
       </p:sp>
       <p:sp>
         <p:nvSpPr>
-          <p:cNvPr id="14" name="TextBox 13"/>
+          <p:cNvPr id="13" name="TextBox 12"/>
           <p:cNvSpPr txBox="1"/>
           <p:nvPr/>
         </p:nvSpPr>
@@ -8219,7 +7985,7 @@
       </p:sp>
       <p:sp>
         <p:nvSpPr>
-          <p:cNvPr id="15" name="Rectangle 14"/>
+          <p:cNvPr id="14" name="Rectangle 13"/>
           <p:cNvSpPr/>
           <p:nvPr/>
         </p:nvSpPr>
@@ -8263,7 +8029,7 @@
       </p:sp>
       <p:sp>
         <p:nvSpPr>
-          <p:cNvPr id="16" name="TextBox 15"/>
+          <p:cNvPr id="15" name="TextBox 14"/>
           <p:cNvSpPr txBox="1"/>
           <p:nvPr/>
         </p:nvSpPr>
@@ -8321,7 +8087,7 @@
       </p:sp>
       <p:sp>
         <p:nvSpPr>
-          <p:cNvPr id="17" name="TextBox 16"/>
+          <p:cNvPr id="16" name="TextBox 15"/>
           <p:cNvSpPr txBox="1"/>
           <p:nvPr/>
         </p:nvSpPr>

</xml_diff>

<commit_message>
Expand abbreviations and add context to the prelim deck
Every abbreviation is now spelled out at first use on the slide itself:
MST, TAC, SRTM, RSMT, PN16, EUD, N-1. Added plain-language context for a
non-specialist audience - what a district-heating network is, why the pipe
layout dominates lifetime cost, and what terrain weighting actually changed.

New slide 8 is a reference slide, deliberately not presented: a full
abbreviation glossary and the data-source list, to jump to during the 5
minutes of question time. Presented running time is unchanged at 5:00.

Also reverted a stray character accidentally typed into the hydraulics.py
docstring.
</commit_message>
<xml_diff>
--- a/build/CLL798_prelim_5min.pptx
+++ b/build/CLL798_prelim_5min.pptx
@@ -12,6 +12,7 @@
     <p:sldId id="260" r:id="rId12"/>
     <p:sldId id="261" r:id="rId13"/>
     <p:sldId id="262" r:id="rId14"/>
+    <p:sldId id="263" r:id="rId15"/>
   </p:sldIdLst>
   <p:sldSz cx="12191695" cy="6858000" type="screen4x3"/>
   <p:notesSz cx="6858000" cy="9144000"/>
@@ -929,6 +930,76 @@
           <a:p>
             <a:r>
               <a:t>CLOSE - 20 s. One sentence: terrain belongs in the edge weight, pressure class belongs in the constraints, reliability belongs in the objective. Then stop and take questions. Do NOT read the four numbers aloud - they are there for the audience to scan.</a:t>
+            </a:r>
+          </a:p>
+        </p:txBody>
+      </p:sp>
+      <p:sp>
+        <p:nvSpPr>
+          <p:cNvPr id="4" name="Slide Number Placeholder 3"/>
+          <p:cNvSpPr>
+            <a:spLocks noGrp="1"/>
+          </p:cNvSpPr>
+          <p:nvPr>
+            <p:ph type="sldNum" idx="5" sz="quarter"/>
+          </p:nvPr>
+        </p:nvSpPr>
+        <p:spPr/>
+      </p:sp>
+    </p:spTree>
+  </p:cSld>
+  <p:clrMapOvr>
+    <a:masterClrMapping/>
+  </p:clrMapOvr>
+</p:notes>
+</file>
+
+<file path=ppt/notesSlides/notesSlide8.xml><?xml version="1.0" encoding="utf-8"?>
+<p:notes xmlns:a="http://schemas.openxmlformats.org/drawingml/2006/main" xmlns:p="http://schemas.openxmlformats.org/presentationml/2006/main" xmlns:r="http://schemas.openxmlformats.org/officeDocument/2006/relationships">
+  <p:cSld>
+    <p:spTree>
+      <p:nvGrpSpPr>
+        <p:cNvPr id="1" name=""/>
+        <p:cNvGrpSpPr/>
+        <p:nvPr/>
+      </p:nvGrpSpPr>
+      <p:grpSpPr>
+        <a:xfrm>
+          <a:off x="0" y="0"/>
+          <a:ext cx="0" cy="0"/>
+          <a:chOff x="0" y="0"/>
+          <a:chExt cx="0" cy="0"/>
+        </a:xfrm>
+      </p:grpSpPr>
+      <p:sp>
+        <p:nvSpPr>
+          <p:cNvPr id="2" name="Slide Image Placeholder 1"/>
+          <p:cNvSpPr>
+            <a:spLocks noGrp="1"/>
+          </p:cNvSpPr>
+          <p:nvPr>
+            <p:ph type="sldImg" idx="2"/>
+          </p:nvPr>
+        </p:nvSpPr>
+        <p:spPr/>
+      </p:sp>
+      <p:sp>
+        <p:nvSpPr>
+          <p:cNvPr id="3" name="Notes Placeholder 2"/>
+          <p:cNvSpPr>
+            <a:spLocks noGrp="1"/>
+          </p:cNvSpPr>
+          <p:nvPr>
+            <p:ph type="body" idx="3" sz="quarter"/>
+          </p:nvPr>
+        </p:nvSpPr>
+        <p:spPr/>
+        <p:txBody>
+          <a:bodyPr/>
+          <a:lstStyle/>
+          <a:p>
+            <a:r>
+              <a:t>BACKUP - do not present. Jump here in QnA if asked what an abbreviation means or where a number came from. Full provenance for every value is in docs/DATA_SOURCES.md.</a:t>
             </a:r>
           </a:p>
         </p:txBody>
@@ -4059,8 +4130,8 @@
         </p:nvSpPr>
         <p:spPr>
           <a:xfrm>
-            <a:off x="475488" y="3520440"/>
-            <a:ext cx="8595360" cy="1097280"/>
+            <a:off x="475488" y="3383280"/>
+            <a:ext cx="9692640" cy="1645920"/>
           </a:xfrm>
           <a:prstGeom prst="rect">
             <a:avLst/>
@@ -4078,17 +4149,36 @@
                 <a:spcPct val="105000"/>
               </a:lnSpc>
               <a:spcAft>
+                <a:spcPts val="1100"/>
+              </a:spcAft>
+            </a:pPr>
+            <a:r>
+              <a:rPr sz="1600" b="0">
+                <a:solidFill>
+                  <a:srgbClr val="B9CDD4"/>
+                </a:solidFill>
+                <a:latin typeface="Segoe UI"/>
+              </a:rPr>
+              <a:t>Graph-theoretic topology optimisation of district-heating pipe networks — on two real German networks, real satellite elevation data, and a transport-phenomena cost model.</a:t>
+            </a:r>
+          </a:p>
+          <a:p>
+            <a:pPr algn="l">
+              <a:lnSpc>
+                <a:spcPct val="100000"/>
+              </a:lnSpc>
+              <a:spcAft>
                 <a:spcPts val="0"/>
               </a:spcAft>
             </a:pPr>
             <a:r>
-              <a:rPr sz="1600" b="0">
-                <a:solidFill>
-                  <a:srgbClr val="B9CDD4"/>
-                </a:solidFill>
-                <a:latin typeface="Segoe UI"/>
-              </a:rPr>
-              <a:t>Graph-theoretic topology optimisation of district-heating pipe networks — on two real German networks, real SRTM terrain, and a transport-phenomena cost model.</a:t>
+              <a:rPr sz="1150" b="0">
+                <a:solidFill>
+                  <a:srgbClr val="8098A1"/>
+                </a:solidFill>
+                <a:latin typeface="Consolas"/>
+              </a:rPr>
+              <a:t>MST = Minimum Spanning Tree    ·    TAC = Total Annual Cost    ·    SRTM = Shuttle Radar Topography Mission</a:t>
             </a:r>
           </a:p>
         </p:txBody>
@@ -4182,7 +4272,7 @@
                 </a:solidFill>
                 <a:latin typeface="Consolas"/>
               </a:rPr>
-              <a:t>TERRAIN</a:t>
+              <a:t>ELEVATION DATA</a:t>
             </a:r>
           </a:p>
           <a:p>
@@ -4198,7 +4288,7 @@
                 </a:solidFill>
                 <a:latin typeface="Segoe UI"/>
               </a:rPr>
-              <a:t>NASA SRTM 30 m</a:t>
+              <a:t>NASA SRTM, 30 m grid</a:t>
             </a:r>
           </a:p>
         </p:txBody>
@@ -4517,8 +4607,8 @@
         </p:blipFill>
         <p:spPr>
           <a:xfrm>
-            <a:off x="475488" y="1600200"/>
-            <a:ext cx="7360920" cy="5159143"/>
+            <a:off x="475488" y="1572768"/>
+            <a:ext cx="7269480" cy="5095054"/>
           </a:xfrm>
           <a:prstGeom prst="rect">
             <a:avLst/>
@@ -4533,8 +4623,8 @@
         </p:nvSpPr>
         <p:spPr>
           <a:xfrm>
-            <a:off x="8110727" y="1600200"/>
-            <a:ext cx="3605479" cy="1371600"/>
+            <a:off x="475488" y="6217920"/>
+            <a:ext cx="7269480" cy="621792"/>
           </a:xfrm>
           <a:prstGeom prst="rect">
             <a:avLst/>
@@ -4548,6 +4638,48 @@
           <a:lstStyle/>
           <a:p>
             <a:pPr algn="l">
+              <a:lnSpc>
+                <a:spcPct val="100000"/>
+              </a:lnSpc>
+              <a:spcAft>
+                <a:spcPts val="0"/>
+              </a:spcAft>
+            </a:pPr>
+            <a:r>
+              <a:rPr sz="1200" b="0">
+                <a:solidFill>
+                  <a:srgbClr val="B9CDD4"/>
+                </a:solidFill>
+                <a:latin typeface="Segoe UI"/>
+              </a:rPr>
+              <a:t>A district-heating network pipes hot water from one central plant to every building in a city district. The buried pipe layout is 80-90 % of lifetime cost, so choosing the topology IS the design decision.</a:t>
+            </a:r>
+          </a:p>
+        </p:txBody>
+      </p:sp>
+      <p:sp>
+        <p:nvSpPr>
+          <p:cNvPr id="7" name="TextBox 6"/>
+          <p:cNvSpPr txBox="1"/>
+          <p:nvPr/>
+        </p:nvSpPr>
+        <p:spPr>
+          <a:xfrm>
+            <a:off x="8110727" y="1572768"/>
+            <a:ext cx="3605479" cy="2057400"/>
+          </a:xfrm>
+          <a:prstGeom prst="rect">
+            <a:avLst/>
+          </a:prstGeom>
+          <a:noFill/>
+        </p:spPr>
+        <p:txBody>
+          <a:bodyPr wrap="square" anchor="t" lIns="0" rIns="0" tIns="0" bIns="0">
+            <a:spAutoFit/>
+          </a:bodyPr>
+          <a:lstStyle/>
+          <a:p>
+            <a:pPr algn="l">
               <a:spcAft>
                 <a:spcPts val="600"/>
               </a:spcAft>
@@ -4569,7 +4701,7 @@
               </a:spcAft>
             </a:pPr>
             <a:r>
-              <a:rPr sz="1300" b="0">
+              <a:rPr sz="1250" b="0">
                 <a:solidFill>
                   <a:srgbClr val="EAF2F2"/>
                 </a:solidFill>
@@ -4585,7 +4717,7 @@
               </a:spcAft>
             </a:pPr>
             <a:r>
-              <a:rPr sz="1300" b="0">
+              <a:rPr sz="1250" b="0">
                 <a:solidFill>
                   <a:srgbClr val="EAF2F2"/>
                 </a:solidFill>
@@ -4601,7 +4733,7 @@
               </a:spcAft>
             </a:pPr>
             <a:r>
-              <a:rPr sz="1300" b="0">
+              <a:rPr sz="1250" b="0">
                 <a:solidFill>
                   <a:srgbClr val="EAF2F2"/>
                 </a:solidFill>
@@ -4613,49 +4745,68 @@
           <a:p>
             <a:pPr>
               <a:spcAft>
+                <a:spcPts val="900"/>
+              </a:spcAft>
+            </a:pPr>
+            <a:r>
+              <a:rPr sz="1250" b="0">
+                <a:solidFill>
+                  <a:srgbClr val="EAF2F2"/>
+                </a:solidFill>
+                <a:latin typeface="Consolas"/>
+              </a:rPr>
+              <a:t>candidates = </a:t>
+            </a:r>
+            <a:r>
+              <a:rPr sz="1250" b="1">
+                <a:solidFill>
+                  <a:srgbClr val="FF7A3D"/>
+                </a:solidFill>
+                <a:latin typeface="Consolas"/>
+              </a:rPr>
+              <a:t>41</a:t>
+            </a:r>
+            <a:r>
+              <a:rPr sz="1250" b="1">
+                <a:solidFill>
+                  <a:srgbClr val="FF7A3D"/>
+                </a:solidFill>
+                <a:latin typeface="Consolas"/>
+              </a:rPr>
+              <a:t>^39 ~ 10^62</a:t>
+            </a:r>
+          </a:p>
+          <a:p>
+            <a:pPr algn="l">
+              <a:lnSpc>
+                <a:spcPct val="98000"/>
+              </a:lnSpc>
+              <a:spcAft>
                 <a:spcPts val="0"/>
               </a:spcAft>
             </a:pPr>
             <a:r>
-              <a:rPr sz="1300" b="0">
-                <a:solidFill>
-                  <a:srgbClr val="EAF2F2"/>
-                </a:solidFill>
-                <a:latin typeface="Consolas"/>
-              </a:rPr>
-              <a:t>candidates = </a:t>
-            </a:r>
-            <a:r>
-              <a:rPr sz="1300" b="1">
-                <a:solidFill>
-                  <a:srgbClr val="FF7A3D"/>
-                </a:solidFill>
-                <a:latin typeface="Consolas"/>
-              </a:rPr>
-              <a:t>41</a:t>
-            </a:r>
-            <a:r>
-              <a:rPr sz="1300" b="1">
-                <a:solidFill>
-                  <a:srgbClr val="FF7A3D"/>
-                </a:solidFill>
-                <a:latin typeface="Consolas"/>
-              </a:rPr>
-              <a:t>^39 ≈ 10^62</a:t>
-            </a:r>
-          </a:p>
-        </p:txBody>
-      </p:sp>
-      <p:sp>
-        <p:nvSpPr>
-          <p:cNvPr id="7" name="Rectangle 6"/>
+              <a:rPr sz="1150" b="0">
+                <a:solidFill>
+                  <a:srgbClr val="5AD2A8"/>
+                </a:solidFill>
+                <a:latin typeface="Segoe UI"/>
+              </a:rPr>
+              <a:t>Minimum Spanning Tree (MST): the cheapest loop-free layout that still reaches every consumer.</a:t>
+            </a:r>
+          </a:p>
+        </p:txBody>
+      </p:sp>
+      <p:sp>
+        <p:nvSpPr>
+          <p:cNvPr id="8" name="Rectangle 7"/>
           <p:cNvSpPr/>
           <p:nvPr/>
         </p:nvSpPr>
         <p:spPr>
           <a:xfrm>
-            <a:off x="8110727" y="3246120"/>
-            <a:ext cx="3605479" cy="1051560"/>
+            <a:off x="8110727" y="3712463"/>
+            <a:ext cx="3605479" cy="969264"/>
           </a:xfrm>
           <a:prstGeom prst="rect">
             <a:avLst/>
@@ -4694,14 +4845,14 @@
       </p:sp>
       <p:sp>
         <p:nvSpPr>
-          <p:cNvPr id="8" name="TextBox 7"/>
+          <p:cNvPr id="9" name="TextBox 8"/>
           <p:cNvSpPr txBox="1"/>
           <p:nvPr/>
         </p:nvSpPr>
         <p:spPr>
           <a:xfrm>
-            <a:off x="8257031" y="3374136"/>
-            <a:ext cx="3312871" cy="795527"/>
+            <a:off x="8257031" y="3840479"/>
+            <a:ext cx="3312871" cy="713232"/>
           </a:xfrm>
           <a:prstGeom prst="rect">
             <a:avLst/>
@@ -4726,7 +4877,7 @@
                 </a:solidFill>
                 <a:latin typeface="Consolas"/>
               </a:rPr>
-              <a:t>REAL DEMAND</a:t>
+              <a:t>REAL HEAT DEMAND</a:t>
             </a:r>
           </a:p>
           <a:p>
@@ -4764,21 +4915,21 @@
                 </a:solidFill>
                 <a:latin typeface="Segoe UI"/>
               </a:rPr>
-              <a:t>67,314 households, from the AixDHN census dataset</a:t>
-            </a:r>
-          </a:p>
-        </p:txBody>
-      </p:sp>
-      <p:sp>
-        <p:nvSpPr>
-          <p:cNvPr id="9" name="Rectangle 8"/>
+              <a:t>67,314 households (AixDHN, RWTH Aachen)</a:t>
+            </a:r>
+          </a:p>
+        </p:txBody>
+      </p:sp>
+      <p:sp>
+        <p:nvSpPr>
+          <p:cNvPr id="10" name="Rectangle 9"/>
           <p:cNvSpPr/>
           <p:nvPr/>
         </p:nvSpPr>
         <p:spPr>
           <a:xfrm>
-            <a:off x="8110727" y="4434840"/>
-            <a:ext cx="3605479" cy="1051560"/>
+            <a:off x="8110727" y="4773168"/>
+            <a:ext cx="3605479" cy="1115568"/>
           </a:xfrm>
           <a:prstGeom prst="rect">
             <a:avLst/>
@@ -4817,14 +4968,14 @@
       </p:sp>
       <p:sp>
         <p:nvSpPr>
-          <p:cNvPr id="10" name="TextBox 9"/>
+          <p:cNvPr id="11" name="TextBox 10"/>
           <p:cNvSpPr txBox="1"/>
           <p:nvPr/>
         </p:nvSpPr>
         <p:spPr>
           <a:xfrm>
-            <a:off x="8257031" y="4562855"/>
-            <a:ext cx="3312871" cy="795527"/>
+            <a:off x="8257031" y="4901183"/>
+            <a:ext cx="3312871" cy="859536"/>
           </a:xfrm>
           <a:prstGeom prst="rect">
             <a:avLst/>
@@ -4849,7 +5000,7 @@
                 </a:solidFill>
                 <a:latin typeface="Consolas"/>
               </a:rPr>
-              <a:t>REAL TERRAIN</a:t>
+              <a:t>REAL ELEVATION</a:t>
             </a:r>
           </a:p>
           <a:p>
@@ -4868,7 +5019,7 @@
                 </a:solidFill>
                 <a:latin typeface="Segoe UI"/>
               </a:rPr>
-              <a:t>29,248 pts</a:t>
+              <a:t>29,248 points</a:t>
             </a:r>
           </a:p>
           <a:p>
@@ -4887,21 +5038,21 @@
                 </a:solidFill>
                 <a:latin typeface="Segoe UI"/>
               </a:rPr>
-              <a:t>NASA SRTM 30 m, sampled every 25 m along each route</a:t>
-            </a:r>
-          </a:p>
-        </p:txBody>
-      </p:sp>
-      <p:sp>
-        <p:nvSpPr>
-          <p:cNvPr id="11" name="Rectangle 10"/>
+              <a:t>NASA satellite data, sampled every 25 m along every candidate route</a:t>
+            </a:r>
+          </a:p>
+        </p:txBody>
+      </p:sp>
+      <p:sp>
+        <p:nvSpPr>
+          <p:cNvPr id="12" name="Rectangle 11"/>
           <p:cNvSpPr/>
           <p:nvPr/>
         </p:nvSpPr>
         <p:spPr>
           <a:xfrm>
-            <a:off x="8110727" y="5623560"/>
-            <a:ext cx="3605479" cy="914400"/>
+            <a:off x="8110727" y="5998464"/>
+            <a:ext cx="3605479" cy="841248"/>
           </a:xfrm>
           <a:prstGeom prst="rect">
             <a:avLst/>
@@ -4940,14 +5091,14 @@
       </p:sp>
       <p:sp>
         <p:nvSpPr>
-          <p:cNvPr id="12" name="TextBox 11"/>
+          <p:cNvPr id="13" name="TextBox 12"/>
           <p:cNvSpPr txBox="1"/>
           <p:nvPr/>
         </p:nvSpPr>
         <p:spPr>
           <a:xfrm>
-            <a:off x="8257031" y="5751576"/>
-            <a:ext cx="3312871" cy="658368"/>
+            <a:off x="8257031" y="6126479"/>
+            <a:ext cx="3312871" cy="585216"/>
           </a:xfrm>
           <a:prstGeom prst="rect">
             <a:avLst/>
@@ -4972,7 +5123,7 @@
                 </a:solidFill>
                 <a:latin typeface="Consolas"/>
               </a:rPr>
-              <a:t>RELIEF CONTRAST</a:t>
+              <a:t>RELIEF = HEIGHT RANGE</a:t>
             </a:r>
           </a:p>
           <a:p>
@@ -5010,7 +5161,7 @@
                 </a:solidFill>
                 <a:latin typeface="Segoe UI"/>
               </a:rPr>
-              <a:t>Bremen against Stuttgart</a:t>
+              <a:t>flat Bremen vs hilly Stuttgart</a:t>
             </a:r>
           </a:p>
         </p:txBody>
@@ -5298,7 +5449,7 @@
                 </a:solidFill>
                 <a:latin typeface="Segoe UI"/>
               </a:rPr>
-              <a:t>−3.0 % TAC</a:t>
+              <a:t>−3.0 % cost</a:t>
             </a:r>
           </a:p>
           <a:p>
@@ -5317,7 +5468,7 @@
                 </a:solidFill>
                 <a:latin typeface="Segoe UI"/>
               </a:rPr>
-              <a:t>23.09 → 22.39 EUR/MWh, for a tree that is 0.03 km LONGER</a:t>
+              <a:t>total annual cost 23.09 → 22.39 EUR per MWh delivered, for a tree that is 0.03 km LONGER</a:t>
             </a:r>
           </a:p>
         </p:txBody>
@@ -5453,8 +5604,8 @@
         </p:nvSpPr>
         <p:spPr>
           <a:xfrm>
-            <a:off x="7973567" y="5184648"/>
-            <a:ext cx="41148" cy="1097280"/>
+            <a:off x="7973567" y="5157216"/>
+            <a:ext cx="41148" cy="1152144"/>
           </a:xfrm>
           <a:prstGeom prst="rect">
             <a:avLst/>
@@ -5497,8 +5648,8 @@
         </p:nvSpPr>
         <p:spPr>
           <a:xfrm>
-            <a:off x="8156447" y="5202936"/>
-            <a:ext cx="3523183" cy="1097280"/>
+            <a:off x="8156447" y="5175503"/>
+            <a:ext cx="3523183" cy="1152144"/>
           </a:xfrm>
           <a:prstGeom prst="rect">
             <a:avLst/>
@@ -5523,7 +5674,7 @@
                 </a:solidFill>
                 <a:latin typeface="Consolas"/>
               </a:rPr>
-              <a:t>WHY IT MATTERS</a:t>
+              <a:t>WHAT WE CHANGED</a:t>
             </a:r>
           </a:p>
           <a:p>
@@ -5542,7 +5693,7 @@
                 </a:solidFill>
                 <a:latin typeface="Segoe UI"/>
               </a:rPr>
-              <a:t>Minimising length and minimising cost are the same problem only on flat ground. The saving is free — same algorithm, better edge weight.</a:t>
+              <a:t>Edge weight is no longer straight-line distance, but true slope length × a trenching multiplier that rises with gradient. Minimum length = minimum cost only on flat ground.</a:t>
             </a:r>
           </a:p>
         </p:txBody>
@@ -5822,7 +5973,7 @@
                 </a:solidFill>
                 <a:latin typeface="Consolas"/>
               </a:rPr>
-              <a:t>PN16 pipe class     </a:t>
+              <a:t>PN16 pipe rating    </a:t>
             </a:r>
             <a:r>
               <a:rPr sz="1350" b="1">
@@ -5869,8 +6020,8 @@
         </p:nvSpPr>
         <p:spPr>
           <a:xfrm>
-            <a:off x="8522208" y="3703320"/>
-            <a:ext cx="3193999" cy="1051560"/>
+            <a:off x="8522208" y="3675887"/>
+            <a:ext cx="3193999" cy="1389888"/>
           </a:xfrm>
           <a:prstGeom prst="rect">
             <a:avLst/>
@@ -5915,8 +6066,8 @@
         </p:nvSpPr>
         <p:spPr>
           <a:xfrm>
-            <a:off x="8668512" y="3831335"/>
-            <a:ext cx="2901391" cy="795527"/>
+            <a:off x="8668512" y="3803903"/>
+            <a:ext cx="2901391" cy="1133856"/>
           </a:xfrm>
           <a:prstGeom prst="rect">
             <a:avLst/>
@@ -5979,7 +6130,7 @@
                 </a:solidFill>
                 <a:latin typeface="Segoe UI"/>
               </a:rPr>
-              <a:t>an exchanger station breaks the static column</a:t>
+              <a:t>PN16 = Pressure Nominal: pipe rated to 16 bar. An exchanger station splits the network so neither half exceeds it.</a:t>
             </a:r>
           </a:p>
         </p:txBody>
@@ -5992,8 +6143,8 @@
         </p:nvSpPr>
         <p:spPr>
           <a:xfrm>
-            <a:off x="8522208" y="4983480"/>
-            <a:ext cx="41148" cy="1554480"/>
+            <a:off x="8522208" y="5248656"/>
+            <a:ext cx="41148" cy="1463040"/>
           </a:xfrm>
           <a:prstGeom prst="rect">
             <a:avLst/>
@@ -6036,8 +6187,8 @@
         </p:nvSpPr>
         <p:spPr>
           <a:xfrm>
-            <a:off x="8705088" y="5001768"/>
-            <a:ext cx="2974543" cy="1554480"/>
+            <a:off x="8705088" y="5266944"/>
+            <a:ext cx="2974543" cy="1463040"/>
           </a:xfrm>
           <a:prstGeom prst="rect">
             <a:avLst/>
@@ -6294,7 +6445,7 @@
           <a:p>
             <a:pPr algn="l">
               <a:spcAft>
-                <a:spcPts val="800"/>
+                <a:spcPts val="600"/>
               </a:spcAft>
             </a:pPr>
             <a:r>
@@ -6304,7 +6455,7 @@
                 </a:solidFill>
                 <a:latin typeface="Consolas"/>
               </a:rPr>
-              <a:t>STUTTGART · WORST SINGLE PIPE FAILURE</a:t>
+              <a:t>STUTTGART  ·  N-1 = LOSS OF ANY ONE PIPE</a:t>
             </a:r>
           </a:p>
           <a:p>
@@ -6314,6 +6465,49 @@
               </a:spcAft>
             </a:pPr>
             <a:r>
+              <a:rPr sz="1000" b="0">
+                <a:solidFill>
+                  <a:srgbClr val="8098A1"/>
+                </a:solidFill>
+                <a:latin typeface="Consolas"/>
+              </a:rPr>
+              <a:t>topology         </a:t>
+            </a:r>
+            <a:r>
+              <a:rPr sz="1000" b="0">
+                <a:solidFill>
+                  <a:srgbClr val="8098A1"/>
+                </a:solidFill>
+                <a:latin typeface="Consolas"/>
+              </a:rPr>
+              <a:t>EUR/MWh  </a:t>
+            </a:r>
+            <a:r>
+              <a:rPr sz="1000" b="0">
+                <a:solidFill>
+                  <a:srgbClr val="8098A1"/>
+                </a:solidFill>
+                <a:latin typeface="Consolas"/>
+              </a:rPr>
+              <a:t>brdg  </a:t>
+            </a:r>
+            <a:r>
+              <a:rPr sz="1000" b="0">
+                <a:solidFill>
+                  <a:srgbClr val="8098A1"/>
+                </a:solidFill>
+                <a:latin typeface="Consolas"/>
+              </a:rPr>
+              <a:t>served</a:t>
+            </a:r>
+          </a:p>
+          <a:p>
+            <a:pPr>
+              <a:spcAft>
+                <a:spcPts val="500"/>
+              </a:spcAft>
+            </a:pPr>
+            <a:r>
               <a:rPr sz="1150" b="0">
                 <a:solidFill>
                   <a:srgbClr val="B9CDD4"/>
@@ -6406,7 +6600,7 @@
                 </a:solidFill>
                 <a:latin typeface="Consolas"/>
               </a:rPr>
-              <a:t>RSMT (cheapest) </a:t>
+              <a:t>RSMT Steiner    </a:t>
             </a:r>
             <a:r>
               <a:rPr sz="1150" b="0">
@@ -6489,8 +6683,8 @@
         </p:nvSpPr>
         <p:spPr>
           <a:xfrm>
-            <a:off x="8385048" y="3977639"/>
-            <a:ext cx="41148" cy="1371600"/>
+            <a:off x="8385048" y="4041648"/>
+            <a:ext cx="41148" cy="1536192"/>
           </a:xfrm>
           <a:prstGeom prst="rect">
             <a:avLst/>
@@ -6533,8 +6727,8 @@
         </p:nvSpPr>
         <p:spPr>
           <a:xfrm>
-            <a:off x="8567928" y="3995927"/>
-            <a:ext cx="3111703" cy="1371600"/>
+            <a:off x="8567928" y="4059935"/>
+            <a:ext cx="3111703" cy="1536192"/>
           </a:xfrm>
           <a:prstGeom prst="rect">
             <a:avLst/>
@@ -6559,7 +6753,7 @@
                 </a:solidFill>
                 <a:latin typeface="Consolas"/>
               </a:rPr>
-              <a:t>ANSWERING THE FAULT QUESTION</a:t>
+              <a:t>DOES A STEINER TREE FIX IT?</a:t>
             </a:r>
           </a:p>
           <a:p>
@@ -6578,7 +6772,7 @@
                 </a:solidFill>
                 <a:latin typeface="Segoe UI"/>
               </a:rPr>
-              <a:t>A Steiner tree is still a tree. It buys length — RSMT is the cheapest topology — but concentrates flow into shared trunks, so it is MORE fragile.</a:t>
+              <a:t>RSMT = Rectilinear Steiner Minimal Tree: extra junction points are allowed, so it is shorter and cheapest here. But it is still a TREE, and it concentrates flow into shared trunks — so it is MORE fragile, not less.</a:t>
             </a:r>
           </a:p>
         </p:txBody>
@@ -6591,8 +6785,8 @@
         </p:nvSpPr>
         <p:spPr>
           <a:xfrm>
-            <a:off x="8385048" y="5532120"/>
-            <a:ext cx="41148" cy="1005840"/>
+            <a:off x="8385048" y="5742432"/>
+            <a:ext cx="41148" cy="1051560"/>
           </a:xfrm>
           <a:prstGeom prst="rect">
             <a:avLst/>
@@ -6635,8 +6829,8 @@
         </p:nvSpPr>
         <p:spPr>
           <a:xfrm>
-            <a:off x="8567928" y="5550407"/>
-            <a:ext cx="3111703" cy="1005840"/>
+            <a:off x="8567928" y="5760720"/>
+            <a:ext cx="3111703" cy="1051560"/>
           </a:xfrm>
           <a:prstGeom prst="rect">
             <a:avLst/>
@@ -6661,7 +6855,7 @@
                 </a:solidFill>
                 <a:latin typeface="Consolas"/>
               </a:rPr>
-              <a:t>THE FIX COSTS 4.3 %</a:t>
+              <a:t>ONLY A LOOP FIXES IT — FOR 4.3 %</a:t>
             </a:r>
           </a:p>
           <a:p>
@@ -6680,7 +6874,7 @@
                 </a:solidFill>
                 <a:latin typeface="Segoe UI"/>
               </a:rPr>
-              <a:t>One redundant pipe: −57 % expected unserved demand, N−1 survival 0 → 68 %.</a:t>
+              <a:t>One redundant pipe: −57 % Expected Unserved Demand (EUD); N-1 survival rises 0 → 68 %.</a:t>
             </a:r>
           </a:p>
         </p:txBody>
@@ -7195,8 +7389,8 @@
         </p:nvSpPr>
         <p:spPr>
           <a:xfrm>
-            <a:off x="7287768" y="5852160"/>
-            <a:ext cx="41148" cy="868680"/>
+            <a:off x="7287768" y="5797296"/>
+            <a:ext cx="41148" cy="932688"/>
           </a:xfrm>
           <a:prstGeom prst="rect">
             <a:avLst/>
@@ -7239,8 +7433,8 @@
         </p:nvSpPr>
         <p:spPr>
           <a:xfrm>
-            <a:off x="7470648" y="5870448"/>
-            <a:ext cx="4208983" cy="868680"/>
+            <a:off x="7470648" y="5815583"/>
+            <a:ext cx="4208983" cy="932688"/>
           </a:xfrm>
           <a:prstGeom prst="rect">
             <a:avLst/>
@@ -7284,7 +7478,7 @@
                 </a:solidFill>
                 <a:latin typeface="Segoe UI"/>
               </a:rPr>
-              <a:t>Reported ESMT/MST = 0.86555 sits below the proved Du–Hwang bound √3/2 = 0.86603.</a:t>
+              <a:t>Their Euclidean Steiner / MST length ratio 0.86555 sits below the proved Du-Hwang lower bound √3/2 = 0.86603.</a:t>
             </a:r>
           </a:p>
         </p:txBody>
@@ -8139,6 +8333,789 @@
                 <a:latin typeface="Segoe UI"/>
               </a:rPr>
               <a:t>AixDHN (RWTH Aachen, MIT)  ·  NASA SRTM 30 m  ·  EN 253  ·  Eurostat  ·  Persson &amp; Werner (2011)</a:t>
+            </a:r>
+          </a:p>
+        </p:txBody>
+      </p:sp>
+    </p:spTree>
+  </p:cSld>
+  <p:clrMapOvr>
+    <a:masterClrMapping/>
+  </p:clrMapOvr>
+</p:sld>
+</file>
+
+<file path=ppt/slides/slide8.xml><?xml version="1.0" encoding="utf-8"?>
+<p:sld xmlns:a="http://schemas.openxmlformats.org/drawingml/2006/main" xmlns:p="http://schemas.openxmlformats.org/presentationml/2006/main" xmlns:r="http://schemas.openxmlformats.org/officeDocument/2006/relationships">
+  <p:cSld>
+    <p:bg>
+      <p:bgPr>
+        <a:solidFill>
+          <a:srgbClr val="0D1A1F"/>
+        </a:solidFill>
+        <a:effectLst/>
+      </p:bgPr>
+    </p:bg>
+    <p:spTree>
+      <p:nvGrpSpPr>
+        <p:cNvPr id="1" name=""/>
+        <p:cNvGrpSpPr/>
+        <p:nvPr/>
+      </p:nvGrpSpPr>
+      <p:grpSpPr/>
+      <p:sp>
+        <p:nvSpPr>
+          <p:cNvPr id="2" name="TextBox 1"/>
+          <p:cNvSpPr txBox="1"/>
+          <p:nvPr/>
+        </p:nvSpPr>
+        <p:spPr>
+          <a:xfrm>
+            <a:off x="475488" y="274320"/>
+            <a:ext cx="11240719" cy="274320"/>
+          </a:xfrm>
+          <a:prstGeom prst="rect">
+            <a:avLst/>
+          </a:prstGeom>
+          <a:noFill/>
+        </p:spPr>
+        <p:txBody>
+          <a:bodyPr wrap="square" anchor="t" lIns="0" rIns="0" tIns="0" bIns="0">
+            <a:spAutoFit/>
+          </a:bodyPr>
+          <a:lstStyle/>
+          <a:p>
+            <a:pPr>
+              <a:spcAft>
+                <a:spcPts val="0"/>
+              </a:spcAft>
+            </a:pPr>
+            <a:r>
+              <a:rPr sz="1150" b="1">
+                <a:solidFill>
+                  <a:srgbClr val="FF7A3D"/>
+                </a:solidFill>
+                <a:latin typeface="Consolas"/>
+              </a:rPr>
+              <a:t>08   </a:t>
+            </a:r>
+            <a:r>
+              <a:rPr sz="1150" b="0">
+                <a:solidFill>
+                  <a:srgbClr val="B9CDD4"/>
+                </a:solidFill>
+                <a:latin typeface="Consolas"/>
+              </a:rPr>
+              <a:t>REFERENCE · NOT PRESENTED</a:t>
+            </a:r>
+          </a:p>
+        </p:txBody>
+      </p:sp>
+      <p:sp>
+        <p:nvSpPr>
+          <p:cNvPr id="3" name="Rectangle 2"/>
+          <p:cNvSpPr/>
+          <p:nvPr/>
+        </p:nvSpPr>
+        <p:spPr>
+          <a:xfrm>
+            <a:off x="475488" y="603504"/>
+            <a:ext cx="11240719" cy="10972"/>
+          </a:xfrm>
+          <a:prstGeom prst="rect">
+            <a:avLst/>
+          </a:prstGeom>
+          <a:solidFill>
+            <a:srgbClr val="24404A"/>
+          </a:solidFill>
+          <a:ln>
+            <a:noFill/>
+          </a:ln>
+          <a:effectLst/>
+        </p:spPr>
+        <p:style>
+          <a:lnRef idx="1">
+            <a:schemeClr val="accent1"/>
+          </a:lnRef>
+          <a:fillRef idx="3">
+            <a:schemeClr val="accent1"/>
+          </a:fillRef>
+          <a:effectRef idx="2">
+            <a:schemeClr val="accent1"/>
+          </a:effectRef>
+          <a:fontRef idx="minor">
+            <a:schemeClr val="lt1"/>
+          </a:fontRef>
+        </p:style>
+        <p:txBody>
+          <a:bodyPr rtlCol="0" anchor="ctr"/>
+          <a:lstStyle/>
+          <a:p>
+            <a:pPr algn="ctr"/>
+          </a:p>
+        </p:txBody>
+      </p:sp>
+      <p:sp>
+        <p:nvSpPr>
+          <p:cNvPr id="4" name="TextBox 3"/>
+          <p:cNvSpPr txBox="1"/>
+          <p:nvPr/>
+        </p:nvSpPr>
+        <p:spPr>
+          <a:xfrm>
+            <a:off x="475488" y="777240"/>
+            <a:ext cx="11240719" cy="822960"/>
+          </a:xfrm>
+          <a:prstGeom prst="rect">
+            <a:avLst/>
+          </a:prstGeom>
+          <a:noFill/>
+        </p:spPr>
+        <p:txBody>
+          <a:bodyPr wrap="square" anchor="t" lIns="0" rIns="0" tIns="0" bIns="0">
+            <a:spAutoFit/>
+          </a:bodyPr>
+          <a:lstStyle/>
+          <a:p>
+            <a:pPr algn="l">
+              <a:lnSpc>
+                <a:spcPct val="92000"/>
+              </a:lnSpc>
+              <a:spcAft>
+                <a:spcPts val="0"/>
+              </a:spcAft>
+            </a:pPr>
+            <a:r>
+              <a:rPr sz="2700" b="1">
+                <a:solidFill>
+                  <a:srgbClr val="EAF2F2"/>
+                </a:solidFill>
+                <a:latin typeface="Segoe UI"/>
+              </a:rPr>
+              <a:t>Abbreviations and data sources</a:t>
+            </a:r>
+          </a:p>
+        </p:txBody>
+      </p:sp>
+      <p:sp>
+        <p:nvSpPr>
+          <p:cNvPr id="5" name="TextBox 4"/>
+          <p:cNvSpPr txBox="1"/>
+          <p:nvPr/>
+        </p:nvSpPr>
+        <p:spPr>
+          <a:xfrm>
+            <a:off x="475488" y="1572768"/>
+            <a:ext cx="5486400" cy="4846320"/>
+          </a:xfrm>
+          <a:prstGeom prst="rect">
+            <a:avLst/>
+          </a:prstGeom>
+          <a:noFill/>
+        </p:spPr>
+        <p:txBody>
+          <a:bodyPr wrap="square" anchor="t" lIns="0" rIns="0" tIns="0" bIns="0">
+            <a:spAutoFit/>
+          </a:bodyPr>
+          <a:lstStyle/>
+          <a:p>
+            <a:pPr algn="l">
+              <a:spcAft>
+                <a:spcPts val="900"/>
+              </a:spcAft>
+            </a:pPr>
+            <a:r>
+              <a:rPr sz="950" b="0">
+                <a:solidFill>
+                  <a:srgbClr val="8098A1"/>
+                </a:solidFill>
+                <a:latin typeface="Consolas"/>
+              </a:rPr>
+              <a:t>ABBREVIATIONS</a:t>
+            </a:r>
+          </a:p>
+          <a:p>
+            <a:pPr>
+              <a:spcAft>
+                <a:spcPts val="600"/>
+              </a:spcAft>
+            </a:pPr>
+            <a:r>
+              <a:rPr sz="1250" b="1">
+                <a:solidFill>
+                  <a:srgbClr val="FF7A3D"/>
+                </a:solidFill>
+                <a:latin typeface="Consolas"/>
+              </a:rPr>
+              <a:t>MST       </a:t>
+            </a:r>
+            <a:r>
+              <a:rPr sz="1250" b="0">
+                <a:solidFill>
+                  <a:srgbClr val="B9CDD4"/>
+                </a:solidFill>
+                <a:latin typeface="Consolas"/>
+              </a:rPr>
+              <a:t>Minimum Spanning Tree</a:t>
+            </a:r>
+          </a:p>
+          <a:p>
+            <a:pPr>
+              <a:spcAft>
+                <a:spcPts val="600"/>
+              </a:spcAft>
+            </a:pPr>
+            <a:r>
+              <a:rPr sz="1250" b="1">
+                <a:solidFill>
+                  <a:srgbClr val="FF7A3D"/>
+                </a:solidFill>
+                <a:latin typeface="Consolas"/>
+              </a:rPr>
+              <a:t>ESMT      </a:t>
+            </a:r>
+            <a:r>
+              <a:rPr sz="1250" b="0">
+                <a:solidFill>
+                  <a:srgbClr val="B9CDD4"/>
+                </a:solidFill>
+                <a:latin typeface="Consolas"/>
+              </a:rPr>
+              <a:t>Euclidean Steiner Minimal Tree</a:t>
+            </a:r>
+          </a:p>
+          <a:p>
+            <a:pPr>
+              <a:spcAft>
+                <a:spcPts val="600"/>
+              </a:spcAft>
+            </a:pPr>
+            <a:r>
+              <a:rPr sz="1250" b="1">
+                <a:solidFill>
+                  <a:srgbClr val="FF7A3D"/>
+                </a:solidFill>
+                <a:latin typeface="Consolas"/>
+              </a:rPr>
+              <a:t>RSMT      </a:t>
+            </a:r>
+            <a:r>
+              <a:rPr sz="1250" b="0">
+                <a:solidFill>
+                  <a:srgbClr val="B9CDD4"/>
+                </a:solidFill>
+                <a:latin typeface="Consolas"/>
+              </a:rPr>
+              <a:t>Rectilinear Steiner Minimal Tree</a:t>
+            </a:r>
+          </a:p>
+          <a:p>
+            <a:pPr>
+              <a:spcAft>
+                <a:spcPts val="600"/>
+              </a:spcAft>
+            </a:pPr>
+            <a:r>
+              <a:rPr sz="1250" b="1">
+                <a:solidFill>
+                  <a:srgbClr val="FF7A3D"/>
+                </a:solidFill>
+                <a:latin typeface="Consolas"/>
+              </a:rPr>
+              <a:t>TAC       </a:t>
+            </a:r>
+            <a:r>
+              <a:rPr sz="1250" b="0">
+                <a:solidFill>
+                  <a:srgbClr val="B9CDD4"/>
+                </a:solidFill>
+                <a:latin typeface="Consolas"/>
+              </a:rPr>
+              <a:t>Total Annual Cost</a:t>
+            </a:r>
+          </a:p>
+          <a:p>
+            <a:pPr>
+              <a:spcAft>
+                <a:spcPts val="600"/>
+              </a:spcAft>
+            </a:pPr>
+            <a:r>
+              <a:rPr sz="1250" b="1">
+                <a:solidFill>
+                  <a:srgbClr val="FF7A3D"/>
+                </a:solidFill>
+                <a:latin typeface="Consolas"/>
+              </a:rPr>
+              <a:t>EUD       </a:t>
+            </a:r>
+            <a:r>
+              <a:rPr sz="1250" b="0">
+                <a:solidFill>
+                  <a:srgbClr val="B9CDD4"/>
+                </a:solidFill>
+                <a:latin typeface="Consolas"/>
+              </a:rPr>
+              <a:t>Expected Unserved Demand</a:t>
+            </a:r>
+          </a:p>
+          <a:p>
+            <a:pPr>
+              <a:spcAft>
+                <a:spcPts val="600"/>
+              </a:spcAft>
+            </a:pPr>
+            <a:r>
+              <a:rPr sz="1250" b="1">
+                <a:solidFill>
+                  <a:srgbClr val="FF7A3D"/>
+                </a:solidFill>
+                <a:latin typeface="Consolas"/>
+              </a:rPr>
+              <a:t>N-1       </a:t>
+            </a:r>
+            <a:r>
+              <a:rPr sz="1250" b="0">
+                <a:solidFill>
+                  <a:srgbClr val="B9CDD4"/>
+                </a:solidFill>
+                <a:latin typeface="Consolas"/>
+              </a:rPr>
+              <a:t>loss of any one component (single contingency)</a:t>
+            </a:r>
+          </a:p>
+          <a:p>
+            <a:pPr>
+              <a:spcAft>
+                <a:spcPts val="600"/>
+              </a:spcAft>
+            </a:pPr>
+            <a:r>
+              <a:rPr sz="1250" b="1">
+                <a:solidFill>
+                  <a:srgbClr val="FF7A3D"/>
+                </a:solidFill>
+                <a:latin typeface="Consolas"/>
+              </a:rPr>
+              <a:t>DN        </a:t>
+            </a:r>
+            <a:r>
+              <a:rPr sz="1250" b="0">
+                <a:solidFill>
+                  <a:srgbClr val="B9CDD4"/>
+                </a:solidFill>
+                <a:latin typeface="Consolas"/>
+              </a:rPr>
+              <a:t>Diameter Nominal - standard pipe size</a:t>
+            </a:r>
+          </a:p>
+          <a:p>
+            <a:pPr>
+              <a:spcAft>
+                <a:spcPts val="600"/>
+              </a:spcAft>
+            </a:pPr>
+            <a:r>
+              <a:rPr sz="1250" b="1">
+                <a:solidFill>
+                  <a:srgbClr val="FF7A3D"/>
+                </a:solidFill>
+                <a:latin typeface="Consolas"/>
+              </a:rPr>
+              <a:t>PN16      </a:t>
+            </a:r>
+            <a:r>
+              <a:rPr sz="1250" b="0">
+                <a:solidFill>
+                  <a:srgbClr val="B9CDD4"/>
+                </a:solidFill>
+                <a:latin typeface="Consolas"/>
+              </a:rPr>
+              <a:t>Pressure Nominal - pipe rated to 16 bar</a:t>
+            </a:r>
+          </a:p>
+          <a:p>
+            <a:pPr>
+              <a:spcAft>
+                <a:spcPts val="600"/>
+              </a:spcAft>
+            </a:pPr>
+            <a:r>
+              <a:rPr sz="1250" b="1">
+                <a:solidFill>
+                  <a:srgbClr val="FF7A3D"/>
+                </a:solidFill>
+                <a:latin typeface="Consolas"/>
+              </a:rPr>
+              <a:t>DEM       </a:t>
+            </a:r>
+            <a:r>
+              <a:rPr sz="1250" b="0">
+                <a:solidFill>
+                  <a:srgbClr val="B9CDD4"/>
+                </a:solidFill>
+                <a:latin typeface="Consolas"/>
+              </a:rPr>
+              <a:t>Digital Elevation Model</a:t>
+            </a:r>
+          </a:p>
+          <a:p>
+            <a:pPr>
+              <a:spcAft>
+                <a:spcPts val="600"/>
+              </a:spcAft>
+            </a:pPr>
+            <a:r>
+              <a:rPr sz="1250" b="1">
+                <a:solidFill>
+                  <a:srgbClr val="FF7A3D"/>
+                </a:solidFill>
+                <a:latin typeface="Consolas"/>
+              </a:rPr>
+              <a:t>SRTM      </a:t>
+            </a:r>
+            <a:r>
+              <a:rPr sz="1250" b="0">
+                <a:solidFill>
+                  <a:srgbClr val="B9CDD4"/>
+                </a:solidFill>
+                <a:latin typeface="Consolas"/>
+              </a:rPr>
+              <a:t>Shuttle Radar Topography Mission (NASA)</a:t>
+            </a:r>
+          </a:p>
+          <a:p>
+            <a:pPr>
+              <a:spcAft>
+                <a:spcPts val="600"/>
+              </a:spcAft>
+            </a:pPr>
+            <a:r>
+              <a:rPr sz="1250" b="1">
+                <a:solidFill>
+                  <a:srgbClr val="FF7A3D"/>
+                </a:solidFill>
+                <a:latin typeface="Consolas"/>
+              </a:rPr>
+              <a:t>LP        </a:t>
+            </a:r>
+            <a:r>
+              <a:rPr sz="1250" b="0">
+                <a:solidFill>
+                  <a:srgbClr val="B9CDD4"/>
+                </a:solidFill>
+                <a:latin typeface="Consolas"/>
+              </a:rPr>
+              <a:t>Linear Programming</a:t>
+            </a:r>
+          </a:p>
+          <a:p>
+            <a:pPr>
+              <a:spcAft>
+                <a:spcPts val="600"/>
+              </a:spcAft>
+            </a:pPr>
+            <a:r>
+              <a:rPr sz="1250" b="1">
+                <a:solidFill>
+                  <a:srgbClr val="FF7A3D"/>
+                </a:solidFill>
+                <a:latin typeface="Consolas"/>
+              </a:rPr>
+              <a:t>lambda_2  </a:t>
+            </a:r>
+            <a:r>
+              <a:rPr sz="1250" b="0">
+                <a:solidFill>
+                  <a:srgbClr val="B9CDD4"/>
+                </a:solidFill>
+                <a:latin typeface="Consolas"/>
+              </a:rPr>
+              <a:t>algebraic connectivity (Fiedler value)</a:t>
+            </a:r>
+          </a:p>
+        </p:txBody>
+      </p:sp>
+      <p:sp>
+        <p:nvSpPr>
+          <p:cNvPr id="6" name="TextBox 5"/>
+          <p:cNvSpPr txBox="1"/>
+          <p:nvPr/>
+        </p:nvSpPr>
+        <p:spPr>
+          <a:xfrm>
+            <a:off x="6327648" y="1572768"/>
+            <a:ext cx="5388559" cy="4846320"/>
+          </a:xfrm>
+          <a:prstGeom prst="rect">
+            <a:avLst/>
+          </a:prstGeom>
+          <a:noFill/>
+        </p:spPr>
+        <p:txBody>
+          <a:bodyPr wrap="square" anchor="t" lIns="0" rIns="0" tIns="0" bIns="0">
+            <a:spAutoFit/>
+          </a:bodyPr>
+          <a:lstStyle/>
+          <a:p>
+            <a:pPr algn="l">
+              <a:spcAft>
+                <a:spcPts val="900"/>
+              </a:spcAft>
+            </a:pPr>
+            <a:r>
+              <a:rPr sz="950" b="0">
+                <a:solidFill>
+                  <a:srgbClr val="8098A1"/>
+                </a:solidFill>
+                <a:latin typeface="Consolas"/>
+              </a:rPr>
+              <a:t>DATA AND SOURCES - ALL REAL, ALL CITED</a:t>
+            </a:r>
+          </a:p>
+          <a:p>
+            <a:pPr algn="l">
+              <a:spcAft>
+                <a:spcPts val="200"/>
+              </a:spcAft>
+            </a:pPr>
+            <a:r>
+              <a:rPr sz="1250" b="1">
+                <a:solidFill>
+                  <a:srgbClr val="5AD2A8"/>
+                </a:solidFill>
+                <a:latin typeface="Segoe UI"/>
+              </a:rPr>
+              <a:t>AixDHN</a:t>
+            </a:r>
+          </a:p>
+          <a:p>
+            <a:pPr algn="l">
+              <a:lnSpc>
+                <a:spcPct val="96000"/>
+              </a:lnSpc>
+              <a:spcAft>
+                <a:spcPts val="800"/>
+              </a:spcAft>
+            </a:pPr>
+            <a:r>
+              <a:rPr sz="1150" b="0">
+                <a:solidFill>
+                  <a:srgbClr val="B9CDD4"/>
+                </a:solidFill>
+                <a:latin typeface="Segoe UI"/>
+              </a:rPr>
+              <a:t>RWTH Aachen EBC, MIT licence - real German district heating areas, demand and census cells</a:t>
+            </a:r>
+          </a:p>
+          <a:p>
+            <a:pPr algn="l">
+              <a:spcAft>
+                <a:spcPts val="200"/>
+              </a:spcAft>
+            </a:pPr>
+            <a:r>
+              <a:rPr sz="1250" b="1">
+                <a:solidFill>
+                  <a:srgbClr val="5AD2A8"/>
+                </a:solidFill>
+                <a:latin typeface="Segoe UI"/>
+              </a:rPr>
+              <a:t>NASA SRTM 30 m</a:t>
+            </a:r>
+          </a:p>
+          <a:p>
+            <a:pPr algn="l">
+              <a:lnSpc>
+                <a:spcPct val="96000"/>
+              </a:lnSpc>
+              <a:spcAft>
+                <a:spcPts val="800"/>
+              </a:spcAft>
+            </a:pPr>
+            <a:r>
+              <a:rPr sz="1150" b="0">
+                <a:solidFill>
+                  <a:srgbClr val="B9CDD4"/>
+                </a:solidFill>
+                <a:latin typeface="Segoe UI"/>
+              </a:rPr>
+              <a:t>elevation, via the OpenTopoData API</a:t>
+            </a:r>
+          </a:p>
+          <a:p>
+            <a:pPr algn="l">
+              <a:spcAft>
+                <a:spcPts val="200"/>
+              </a:spcAft>
+            </a:pPr>
+            <a:r>
+              <a:rPr sz="1250" b="1">
+                <a:solidFill>
+                  <a:srgbClr val="5AD2A8"/>
+                </a:solidFill>
+                <a:latin typeface="Segoe UI"/>
+              </a:rPr>
+              <a:t>EN 253</a:t>
+            </a:r>
+          </a:p>
+          <a:p>
+            <a:pPr algn="l">
+              <a:lnSpc>
+                <a:spcPct val="96000"/>
+              </a:lnSpc>
+              <a:spcAft>
+                <a:spcPts val="800"/>
+              </a:spcAft>
+            </a:pPr>
+            <a:r>
+              <a:rPr sz="1150" b="0">
+                <a:solidFill>
+                  <a:srgbClr val="B9CDD4"/>
+                </a:solidFill>
+                <a:latin typeface="Segoe UI"/>
+              </a:rPr>
+              <a:t>European standard for pre-insulated bonded pipe - the diameter catalogue</a:t>
+            </a:r>
+          </a:p>
+          <a:p>
+            <a:pPr algn="l">
+              <a:spcAft>
+                <a:spcPts val="200"/>
+              </a:spcAft>
+            </a:pPr>
+            <a:r>
+              <a:rPr sz="1250" b="1">
+                <a:solidFill>
+                  <a:srgbClr val="5AD2A8"/>
+                </a:solidFill>
+                <a:latin typeface="Segoe UI"/>
+              </a:rPr>
+              <a:t>Persson &amp; Werner 2011</a:t>
+            </a:r>
+          </a:p>
+          <a:p>
+            <a:pPr algn="l">
+              <a:lnSpc>
+                <a:spcPct val="96000"/>
+              </a:lnSpc>
+              <a:spcAft>
+                <a:spcPts val="800"/>
+              </a:spcAft>
+            </a:pPr>
+            <a:r>
+              <a:rPr sz="1150" b="0">
+                <a:solidFill>
+                  <a:srgbClr val="B9CDD4"/>
+                </a:solidFill>
+                <a:latin typeface="Segoe UI"/>
+              </a:rPr>
+              <a:t>district-heating trench cost function</a:t>
+            </a:r>
+          </a:p>
+          <a:p>
+            <a:pPr algn="l">
+              <a:spcAft>
+                <a:spcPts val="200"/>
+              </a:spcAft>
+            </a:pPr>
+            <a:r>
+              <a:rPr sz="1250" b="1">
+                <a:solidFill>
+                  <a:srgbClr val="5AD2A8"/>
+                </a:solidFill>
+                <a:latin typeface="Segoe UI"/>
+              </a:rPr>
+              <a:t>Valincius et al. 2015</a:t>
+            </a:r>
+          </a:p>
+          <a:p>
+            <a:pPr algn="l">
+              <a:lnSpc>
+                <a:spcPct val="96000"/>
+              </a:lnSpc>
+              <a:spcAft>
+                <a:spcPts val="800"/>
+              </a:spcAft>
+            </a:pPr>
+            <a:r>
+              <a:rPr sz="1150" b="0">
+                <a:solidFill>
+                  <a:srgbClr val="B9CDD4"/>
+                </a:solidFill>
+                <a:latin typeface="Segoe UI"/>
+              </a:rPr>
+              <a:t>pipe failure rates, 0.02-0.31 per km-year</a:t>
+            </a:r>
+          </a:p>
+          <a:p>
+            <a:pPr algn="l">
+              <a:spcAft>
+                <a:spcPts val="200"/>
+              </a:spcAft>
+            </a:pPr>
+            <a:r>
+              <a:rPr sz="1250" b="1">
+                <a:solidFill>
+                  <a:srgbClr val="5AD2A8"/>
+                </a:solidFill>
+                <a:latin typeface="Segoe UI"/>
+              </a:rPr>
+              <a:t>Eurostat H2 2025</a:t>
+            </a:r>
+          </a:p>
+          <a:p>
+            <a:pPr algn="l">
+              <a:lnSpc>
+                <a:spcPct val="96000"/>
+              </a:lnSpc>
+              <a:spcAft>
+                <a:spcPts val="800"/>
+              </a:spcAft>
+            </a:pPr>
+            <a:r>
+              <a:rPr sz="1150" b="0">
+                <a:solidFill>
+                  <a:srgbClr val="B9CDD4"/>
+                </a:solidFill>
+                <a:latin typeface="Segoe UI"/>
+              </a:rPr>
+              <a:t>German industrial electricity, 0.1922 EUR/kWh</a:t>
+            </a:r>
+          </a:p>
+          <a:p>
+            <a:pPr algn="l">
+              <a:spcAft>
+                <a:spcPts val="200"/>
+              </a:spcAft>
+            </a:pPr>
+            <a:r>
+              <a:rPr sz="1250" b="1">
+                <a:solidFill>
+                  <a:srgbClr val="5AD2A8"/>
+                </a:solidFill>
+                <a:latin typeface="Segoe UI"/>
+              </a:rPr>
+              <a:t>Gao et al. 2020</a:t>
+            </a:r>
+          </a:p>
+          <a:p>
+            <a:pPr algn="l">
+              <a:lnSpc>
+                <a:spcPct val="96000"/>
+              </a:lnSpc>
+              <a:spcAft>
+                <a:spcPts val="800"/>
+              </a:spcAft>
+            </a:pPr>
+            <a:r>
+              <a:rPr sz="1150" b="0">
+                <a:solidFill>
+                  <a:srgbClr val="B9CDD4"/>
+                </a:solidFill>
+                <a:latin typeface="Segoe UI"/>
+              </a:rPr>
+              <a:t>the reproduced paper, Chem. Eng. Trans. 81</a:t>
             </a:r>
           </a:p>
         </p:txBody>

</xml_diff>